<commit_message>
fix(templates): restore readable subtitles and retain visual repair evidence
</commit_message>
<xml_diff>
--- a/templates/modern.pptx
+++ b/templates/modern.pptx
@@ -1093,8 +1093,8 @@
               </a:gs>
               <a:gs pos="100000">
                 <a:schemeClr val="accent2">
-                  <a:lumMod val="97000"/>
-                  <a:lumOff val="3000"/>
+                  <a:lumMod val="50000"/>
+                  <a:lumOff val="0"/>
                 </a:schemeClr>
               </a:gs>
               <a:gs pos="50000">
@@ -1534,8 +1534,8 @@
               </a:gs>
               <a:gs pos="100000">
                 <a:schemeClr val="accent2">
-                  <a:lumMod val="97000"/>
-                  <a:lumOff val="3000"/>
+                  <a:lumMod val="50000"/>
+                  <a:lumOff val="0"/>
                 </a:schemeClr>
               </a:gs>
               <a:gs pos="50000">

</xml_diff>

<commit_message>
fix(templates): retain modern gradient as a reviewed thin footer accent
</commit_message>
<xml_diff>
--- a/templates/modern.pptx
+++ b/templates/modern.pptx
@@ -1382,8 +1382,8 @@
         </p:nvSpPr>
         <p:spPr>
           <a:xfrm>
-            <a:off x="5291586" y="6303963"/>
-            <a:ext cx="4287186" cy="554037"/>
+            <a:off x="0" y="6781800"/>
+            <a:ext cx="12192000" cy="76200"/>
           </a:xfrm>
           <a:prstGeom prst="rect">
             <a:avLst/>

</xml_diff>

<commit_message>
fix(templates): restore reviewed modern bullet hierarchy
</commit_message>
<xml_diff>
--- a/templates/modern.pptx
+++ b/templates/modern.pptx
@@ -1271,7 +1271,7 @@
               <a:buChar char="§"/>
               <a:defRPr sz="1800"/>
             </a:lvl1pPr>
-            <a:lvl2pPr marL="228600" indent="-228600">
+            <a:lvl2pPr marL="457200" indent="-228600">
               <a:spcBef>
                 <a:spcPts val="1000"/>
               </a:spcBef>
@@ -1285,7 +1285,7 @@
               <a:buChar char="§"/>
               <a:defRPr sz="1800"/>
             </a:lvl2pPr>
-            <a:lvl3pPr marL="228600" indent="-228600">
+            <a:lvl3pPr marL="685800" indent="-228600">
               <a:spcBef>
                 <a:spcPts val="1000"/>
               </a:spcBef>
@@ -1299,7 +1299,7 @@
               <a:buChar char="§"/>
               <a:defRPr sz="1800"/>
             </a:lvl3pPr>
-            <a:lvl4pPr marL="228600" indent="-228600">
+            <a:lvl4pPr marL="914400" indent="-228600">
               <a:spcBef>
                 <a:spcPts val="1000"/>
               </a:spcBef>
@@ -1313,7 +1313,7 @@
               <a:buChar char="§"/>
               <a:defRPr sz="1800"/>
             </a:lvl4pPr>
-            <a:lvl5pPr marL="228600" indent="-228600">
+            <a:lvl5pPr marL="1143000" indent="-228600">
               <a:spcBef>
                 <a:spcPts val="1000"/>
               </a:spcBef>
@@ -2025,7 +2025,7 @@
               <a:buChar char="§"/>
               <a:defRPr sz="1800"/>
             </a:lvl1pPr>
-            <a:lvl2pPr marL="228600" indent="-228600">
+            <a:lvl2pPr marL="457200" indent="-228600">
               <a:spcBef>
                 <a:spcPts val="1000"/>
               </a:spcBef>
@@ -2091,7 +2091,7 @@
               <a:buChar char="§"/>
               <a:defRPr sz="1800"/>
             </a:lvl1pPr>
-            <a:lvl2pPr marL="228600" indent="-228600">
+            <a:lvl2pPr marL="457200" indent="-228600">
               <a:spcBef>
                 <a:spcPts val="1000"/>
               </a:spcBef>

</xml_diff>